<commit_message>
They are departments, not hats
The word read as odd out loud, and a workshop deck is read out loud. Departments
everywhere in the slides, and the framework's own wording follows — for a company
its divisions, for one person the parts of their own job.

Co-Authored-By: Claude Opus 5 <noreply@anthropic.com>
Claude-Session: https://claude.ai/code/session_01GU6RhWctnBpcS6dNZ87S1b
</commit_message>
<xml_diff>
--- a/docs/Your AI Second Brain — a hands-on hour.pptx
+++ b/docs/Your AI Second Brain — a hands-on hour.pptx
@@ -783,7 +783,7 @@
           <a:p>
             <a:r>
               <a:rPr lang="en-US" dirty="0"/>
-              <a:t>Give this a full five minutes and walk the room. The twelve-hat instinct is universal; push back. Ask two or three people to say theirs out loud — it unsticks everyone else.</a:t>
+              <a:t>Give this a full five minutes and walk the room. The twelve-department instinct is universal; push back. Ask two or three people to say theirs out loud — it unsticks everyone else.</a:t>
             </a:r>
             <a:endParaRPr lang="en-US" dirty="0"/>
           </a:p>
@@ -3743,7 +3743,7 @@
                 <a:ea typeface="Public Sans" pitchFamily="34" charset="-122"/>
                 <a:cs typeface="Public Sans" pitchFamily="34" charset="-120"/>
               </a:rPr>
-              <a:t>Name your hats</a:t>
+              <a:t>Name your departments</a:t>
             </a:r>
             <a:endParaRPr lang="en-US" sz="3200" dirty="0"/>
           </a:p>
@@ -3897,7 +3897,7 @@
                 <a:ea typeface="Public Sans" pitchFamily="34" charset="-122"/>
                 <a:cs typeface="Public Sans" pitchFamily="34" charset="-120"/>
               </a:rPr>
-              <a:t>one note per hat appears in Obsidian, each with an assistant attached to it.</a:t>
+              <a:t>one note per department appears in Obsidian, each with an assistant attached to it.</a:t>
             </a:r>
             <a:endParaRPr lang="en-US" sz="1450" dirty="0"/>
           </a:p>
@@ -3963,7 +3963,7 @@
                 <a:ea typeface="Courier New" pitchFamily="34" charset="-122"/>
                 <a:cs typeface="Courier New" pitchFamily="34" charset="-120"/>
               </a:rPr>
-              <a:t>A DEPARTMENT IS A HAT</a:t>
+              <a:t>WHAT COUNTS AS ONE</a:t>
             </a:r>
             <a:endParaRPr lang="en-US" sz="950" dirty="0"/>
           </a:p>
@@ -4197,7 +4197,7 @@
                 <a:ea typeface="Public Sans" pitchFamily="34" charset="-122"/>
                 <a:cs typeface="Public Sans" pitchFamily="34" charset="-120"/>
               </a:rPr>
-              <a:t>If two of them would never disagree about anything, they are one hat. You can add another next week in one sentence.</a:t>
+              <a:t>If two of them would never disagree about anything, they are one department. You can add another next week in one sentence.</a:t>
             </a:r>
             <a:endParaRPr lang="en-US" sz="1300" dirty="0"/>
           </a:p>
@@ -4373,7 +4373,7 @@
                 <a:ea typeface="Public Sans" pitchFamily="34" charset="-122"/>
                 <a:cs typeface="Public Sans" pitchFamily="34" charset="-120"/>
               </a:rPr>
-              <a:t>Each hat says where it stops — and that matters more than what it does</a:t>
+              <a:t>Each one says where it stops — and that matters more than what it does</a:t>
             </a:r>
             <a:endParaRPr lang="en-US" sz="3000" dirty="0"/>
           </a:p>
@@ -4388,11 +4388,11 @@
         <p:spPr>
           <a:xfrm>
             <a:off x="777240" y="2286000"/>
-            <a:ext cx="5029200" cy="2286000"/>
+            <a:ext cx="5029200" cy="2560320"/>
           </a:xfrm>
           <a:prstGeom prst="roundRect">
             <a:avLst>
-              <a:gd name="adj" fmla="val 2400"/>
+              <a:gd name="adj" fmla="val 2143"/>
             </a:avLst>
           </a:prstGeom>
           <a:solidFill>
@@ -4496,7 +4496,7 @@
         <p:spPr>
           <a:xfrm>
             <a:off x="1051560" y="3291840"/>
-            <a:ext cx="4480560" cy="1042416"/>
+            <a:ext cx="4480560" cy="1316736"/>
           </a:xfrm>
           <a:prstGeom prst="rect">
             <a:avLst/>
@@ -4538,11 +4538,11 @@
         <p:spPr>
           <a:xfrm>
             <a:off x="6172200" y="2286000"/>
-            <a:ext cx="5029200" cy="2286000"/>
+            <a:ext cx="5029200" cy="2560320"/>
           </a:xfrm>
           <a:prstGeom prst="roundRect">
             <a:avLst>
-              <a:gd name="adj" fmla="val 2400"/>
+              <a:gd name="adj" fmla="val 2143"/>
             </a:avLst>
           </a:prstGeom>
           <a:solidFill>
@@ -4646,7 +4646,7 @@
         <p:spPr>
           <a:xfrm>
             <a:off x="6446520" y="3291840"/>
-            <a:ext cx="4480560" cy="1042416"/>
+            <a:ext cx="4480560" cy="1316736"/>
           </a:xfrm>
           <a:prstGeom prst="rect">
             <a:avLst/>
@@ -4673,7 +4673,7 @@
                 <a:ea typeface="Public Sans" pitchFamily="34" charset="-122"/>
                 <a:cs typeface="Public Sans" pitchFamily="34" charset="-120"/>
               </a:rPr>
-              <a:t>Your Reporting hat does not decide what to do about a bad number. Your Client Work hat does not set prices.</a:t>
+              <a:t>Your Reporting department does not decide what to do about a bad number. Your Client Work department does not set prices.</a:t>
             </a:r>
             <a:endParaRPr lang="en-US" sz="1300" dirty="0"/>
           </a:p>
@@ -4702,7 +4702,7 @@
                 <a:ea typeface="Public Sans" pitchFamily="34" charset="-122"/>
                 <a:cs typeface="Public Sans" pitchFamily="34" charset="-120"/>
               </a:rPr>
-              <a:t>Write that down and the assistant hands the question back instead of inventing an answer.</a:t>
+              <a:t>Write that down and the assistant hands the question back instead of inventing one.</a:t>
             </a:r>
             <a:endParaRPr lang="en-US" sz="1300" dirty="0"/>
           </a:p>
@@ -4716,12 +4716,12 @@
         </p:nvSpPr>
         <p:spPr>
           <a:xfrm>
-            <a:off x="777240" y="4846320"/>
-            <a:ext cx="10607040" cy="914400"/>
+            <a:off x="777240" y="5074920"/>
+            <a:ext cx="10607040" cy="868680"/>
           </a:xfrm>
           <a:prstGeom prst="roundRect">
             <a:avLst>
-              <a:gd name="adj" fmla="val 6000"/>
+              <a:gd name="adj" fmla="val 6316"/>
             </a:avLst>
           </a:prstGeom>
           <a:solidFill>
@@ -4743,8 +4743,8 @@
         </p:nvSpPr>
         <p:spPr>
           <a:xfrm>
-            <a:off x="1097280" y="4846320"/>
-            <a:ext cx="10058400" cy="914400"/>
+            <a:off x="1097280" y="5074920"/>
+            <a:ext cx="10058400" cy="868680"/>
           </a:xfrm>
           <a:prstGeom prst="rect">
             <a:avLst/>
@@ -5006,7 +5006,7 @@
                 <a:ea typeface="Public Sans" pitchFamily="34" charset="-122"/>
                 <a:cs typeface="Public Sans" pitchFamily="34" charset="-120"/>
               </a:rPr>
-              <a:t>Each hat note compiles into an assistant that answers for that hat and nothing else. Adding one next month is the same sentence again.</a:t>
+              <a:t>Each department note compiles into an assistant that answers for that department and nothing else. Adding one next month is the same sentence again.</a:t>
             </a:r>
             <a:endParaRPr lang="en-US" sz="1500" dirty="0"/>
           </a:p>
@@ -5732,7 +5732,7 @@
                 <a:ea typeface="Courier New" pitchFamily="34" charset="-122"/>
                 <a:cs typeface="Courier New" pitchFamily="34" charset="-120"/>
               </a:rPr>
-              <a:t>Four of them are your hats. The fifth keeps the writing itself honest.</a:t>
+              <a:t>Four of them are parts of your job. The fifth keeps the writing itself honest.</a:t>
             </a:r>
             <a:endParaRPr lang="en-US" sz="1000" dirty="0"/>
           </a:p>
@@ -5908,7 +5908,7 @@
                 <a:ea typeface="Public Sans" pitchFamily="34" charset="-122"/>
                 <a:cs typeface="Public Sans" pitchFamily="34" charset="-120"/>
               </a:rPr>
-              <a:t>Your hats, on the page, counted</a:t>
+              <a:t>Your departments, on the page, counted</a:t>
             </a:r>
             <a:endParaRPr lang="en-US" sz="3000" dirty="0"/>
           </a:p>
@@ -7513,7 +7513,7 @@
                 <a:ea typeface="Public Sans" pitchFamily="34" charset="-122"/>
                 <a:cs typeface="Public Sans" pitchFamily="34" charset="-120"/>
               </a:rPr>
-              <a:t>Add the hat you forgot today</a:t>
+              <a:t>Add the one you forgot today</a:t>
             </a:r>
             <a:endParaRPr lang="en-US" sz="1600" dirty="0"/>
           </a:p>
@@ -8285,7 +8285,7 @@
                 <a:ea typeface="Public Sans" pitchFamily="34" charset="-122"/>
                 <a:cs typeface="Public Sans" pitchFamily="34" charset="-120"/>
               </a:rPr>
-              <a:t>One per hat you wear. Each knows what it is responsible for, and — the part that matters — where it stops.</a:t>
+              <a:t>One per department — one per part of your job. Each knows what it is responsible for, and — the part that matters — where it stops.</a:t>
             </a:r>
             <a:endParaRPr lang="en-US" sz="1250" dirty="0"/>
           </a:p>

</xml_diff>